<commit_message>
slides update. News update.
</commit_message>
<xml_diff>
--- a/slides/complexinput.pptx
+++ b/slides/complexinput.pptx
@@ -293,7 +293,7 @@
               <a:pPr>
                 <a:defRPr/>
               </a:pPr>
-              <a:t>05-05-2025</a:t>
+              <a:t>16-04-2026</a:t>
             </a:fld>
             <a:endParaRPr lang="en-US"/>
           </a:p>
@@ -2200,7 +2200,7 @@
               <a:pPr>
                 <a:defRPr/>
               </a:pPr>
-              <a:t>05-05-2025</a:t>
+              <a:t>16-04-2026</a:t>
             </a:fld>
             <a:endParaRPr lang="en-US"/>
           </a:p>
@@ -2390,7 +2390,7 @@
               <a:pPr>
                 <a:defRPr/>
               </a:pPr>
-              <a:t>05-05-2025</a:t>
+              <a:t>16-04-2026</a:t>
             </a:fld>
             <a:endParaRPr lang="en-US"/>
           </a:p>
@@ -2590,7 +2590,7 @@
               <a:pPr>
                 <a:defRPr/>
               </a:pPr>
-              <a:t>05-05-2025</a:t>
+              <a:t>16-04-2026</a:t>
             </a:fld>
             <a:endParaRPr lang="en-US"/>
           </a:p>
@@ -2786,7 +2786,7 @@
               <a:pPr>
                 <a:defRPr/>
               </a:pPr>
-              <a:t>05-05-2025</a:t>
+              <a:t>16-04-2026</a:t>
             </a:fld>
             <a:endParaRPr lang="en-US"/>
           </a:p>
@@ -3053,7 +3053,7 @@
               <a:pPr>
                 <a:defRPr/>
               </a:pPr>
-              <a:t>05-05-2025</a:t>
+              <a:t>16-04-2026</a:t>
             </a:fld>
             <a:endParaRPr lang="en-US"/>
           </a:p>
@@ -3360,7 +3360,7 @@
               <a:pPr>
                 <a:defRPr/>
               </a:pPr>
-              <a:t>05-05-2025</a:t>
+              <a:t>16-04-2026</a:t>
             </a:fld>
             <a:endParaRPr lang="en-US"/>
           </a:p>
@@ -3801,7 +3801,7 @@
               <a:pPr>
                 <a:defRPr/>
               </a:pPr>
-              <a:t>05-05-2025</a:t>
+              <a:t>16-04-2026</a:t>
             </a:fld>
             <a:endParaRPr lang="en-US"/>
           </a:p>
@@ -3946,7 +3946,7 @@
               <a:pPr>
                 <a:defRPr/>
               </a:pPr>
-              <a:t>05-05-2025</a:t>
+              <a:t>16-04-2026</a:t>
             </a:fld>
             <a:endParaRPr lang="en-US"/>
           </a:p>
@@ -4063,7 +4063,7 @@
               <a:pPr>
                 <a:defRPr/>
               </a:pPr>
-              <a:t>05-05-2025</a:t>
+              <a:t>16-04-2026</a:t>
             </a:fld>
             <a:endParaRPr lang="en-US"/>
           </a:p>
@@ -4360,7 +4360,7 @@
               <a:pPr>
                 <a:defRPr/>
               </a:pPr>
-              <a:t>05-05-2025</a:t>
+              <a:t>16-04-2026</a:t>
             </a:fld>
             <a:endParaRPr lang="en-US"/>
           </a:p>
@@ -4640,7 +4640,7 @@
               <a:pPr>
                 <a:defRPr/>
               </a:pPr>
-              <a:t>05-05-2025</a:t>
+              <a:t>16-04-2026</a:t>
             </a:fld>
             <a:endParaRPr lang="en-US"/>
           </a:p>
@@ -4896,7 +4896,7 @@
               <a:pPr>
                 <a:defRPr/>
               </a:pPr>
-              <a:t>05-05-2025</a:t>
+              <a:t>16-04-2026</a:t>
             </a:fld>
             <a:endParaRPr lang="en-US"/>
           </a:p>
@@ -5502,7 +5502,7 @@
             </a:pPr>
             <a:r>
               <a:rPr lang="en-US" dirty="0"/>
-              <a:t>2022/23</a:t>
+              <a:t>2025/26</a:t>
             </a:r>
           </a:p>
           <a:p>
@@ -5513,20 +5513,8 @@
               <a:defRPr/>
             </a:pPr>
             <a:r>
-              <a:rPr lang="en-US" dirty="0" err="1"/>
-              <a:t>Wishnu</a:t>
-            </a:r>
-            <a:r>
               <a:rPr lang="en-US" dirty="0"/>
-              <a:t> </a:t>
-            </a:r>
-            <a:r>
-              <a:rPr lang="en-US" dirty="0" err="1"/>
-              <a:t>Prasetya</a:t>
-            </a:r>
-            <a:r>
-              <a:rPr lang="en-US" dirty="0"/>
-              <a:t> &amp; Gabriele Keller</a:t>
+              <a:t>Wishnu Prasetya &amp; Paige North</a:t>
             </a:r>
           </a:p>
           <a:p>

</xml_diff>